<commit_message>
Move total-revenue-by-source slide ahead of digital YTD summary
Co-Authored-By: Claude Opus 5.5 <noreply@anthropic.com>
Claude-Session: https://claude.ai/code/session_01Uh1Zy2kJM6EXCLGhh2VL1n
</commit_message>
<xml_diff>
--- a/Coastal-Air-Plus-YTD-Performance-Sep2026.pptx
+++ b/Coastal-Air-Plus-YTD-Performance-Sep2026.pptx
@@ -6,8 +6,8 @@
   </p:sldMasterIdLst>
   <p:sldIdLst>
     <p:sldId id="256" r:id="rId7"/>
+    <p:sldId id="268" r:id="rId20"/>
     <p:sldId id="257" r:id="rId9"/>
-    <p:sldId id="268" r:id="rId20"/>
     <p:sldId id="258" r:id="rId10"/>
     <p:sldId id="259" r:id="rId11"/>
     <p:sldId id="260" r:id="rId12"/>
@@ -10265,7 +10265,7 @@
                 </a:solidFill>
                 <a:latin typeface="Arial"/>
               </a:rPr>
-              <a:t>Adding TV and direct mail: $1.16M in total revenue</a:t>
+              <a:t>Total revenue: $1.16M across digital, TV and direct mail</a:t>
             </a:r>
           </a:p>
         </p:txBody>
@@ -10335,7 +10335,7 @@
                 </a:solidFill>
                 <a:latin typeface="Arial"/>
               </a:rPr>
-              <a:t>3</a:t>
+              <a:t>2</a:t>
             </a:r>
           </a:p>
         </p:txBody>
@@ -11379,7 +11379,7 @@
                 </a:solidFill>
                 <a:latin typeface="Arial"/>
               </a:rPr>
-              <a:t>2</a:t>
+              <a:t>3</a:t>
             </a:r>
           </a:p>
         </p:txBody>

</xml_diff>

<commit_message>
Add Digital Advertising section divider as slide 4
Co-Authored-By: Claude Opus 5.5 <noreply@anthropic.com>
Claude-Session: https://claude.ai/code/session_01Uh1Zy2kJM6EXCLGhh2VL1n
</commit_message>
<xml_diff>
--- a/Coastal-Air-Plus-YTD-Performance-Sep2026.pptx
+++ b/Coastal-Air-Plus-YTD-Performance-Sep2026.pptx
@@ -8,6 +8,7 @@
     <p:sldId id="256" r:id="rId7"/>
     <p:sldId id="268" r:id="rId20"/>
     <p:sldId id="257" r:id="rId9"/>
+    <p:sldId id="269" r:id="rId21"/>
     <p:sldId id="258" r:id="rId10"/>
     <p:sldId id="259" r:id="rId11"/>
     <p:sldId id="260" r:id="rId12"/>
@@ -4646,7 +4647,7 @@
                 </a:solidFill>
                 <a:latin typeface="Arial"/>
               </a:rPr>
-              <a:t>11</a:t>
+              <a:t>12</a:t>
             </a:r>
           </a:p>
         </p:txBody>
@@ -7413,7 +7414,7 @@
                 </a:solidFill>
                 <a:latin typeface="Arial"/>
               </a:rPr>
-              <a:t>12</a:t>
+              <a:t>13</a:t>
             </a:r>
           </a:p>
         </p:txBody>
@@ -11261,6 +11262,137 @@
 </p:sld>
 </file>
 
+<file path=ppt/slides/slide14.xml><?xml version="1.0" encoding="utf-8"?>
+<p:sld xmlns:a="http://schemas.openxmlformats.org/drawingml/2006/main" xmlns:p="http://schemas.openxmlformats.org/presentationml/2006/main" xmlns:r="http://schemas.openxmlformats.org/officeDocument/2006/relationships">
+  <p:cSld>
+    <p:bg>
+      <p:bgPr>
+        <a:solidFill>
+          <a:srgbClr val="14213D"/>
+        </a:solidFill>
+        <a:effectLst/>
+      </p:bgPr>
+    </p:bg>
+    <p:spTree>
+      <p:nvGrpSpPr>
+        <p:cNvPr id="1" name=""/>
+        <p:cNvGrpSpPr/>
+        <p:nvPr/>
+      </p:nvGrpSpPr>
+      <p:grpSpPr/>
+      <p:sp>
+        <p:nvSpPr>
+          <p:cNvPr id="2" name="Eyebrow"/>
+          <p:cNvSpPr txBox="1"/>
+          <p:nvPr/>
+        </p:nvSpPr>
+        <p:spPr>
+          <a:xfrm>
+            <a:off x="548640" y="2468880"/>
+            <a:ext cx="11094415" cy="365760"/>
+          </a:xfrm>
+          <a:prstGeom prst="rect">
+            <a:avLst/>
+          </a:prstGeom>
+          <a:noFill/>
+        </p:spPr>
+        <p:txBody>
+          <a:bodyPr wrap="square" anchor="t" lIns="0" rIns="0" tIns="0" bIns="0">
+            <a:spAutoFit/>
+          </a:bodyPr>
+          <a:lstStyle/>
+          <a:p>
+            <a:pPr algn="l"/>
+            <a:r>
+              <a:rPr sz="1600" b="1">
+                <a:solidFill>
+                  <a:srgbClr val="F2A65A"/>
+                </a:solidFill>
+                <a:latin typeface="Arial"/>
+              </a:rPr>
+              <a:t>SECTION</a:t>
+            </a:r>
+          </a:p>
+        </p:txBody>
+      </p:sp>
+      <p:sp>
+        <p:nvSpPr>
+          <p:cNvPr id="3" name="Title"/>
+          <p:cNvSpPr txBox="1"/>
+          <p:nvPr/>
+        </p:nvSpPr>
+        <p:spPr>
+          <a:xfrm>
+            <a:off x="548640" y="2926080"/>
+            <a:ext cx="11094415" cy="914400"/>
+          </a:xfrm>
+          <a:prstGeom prst="rect">
+            <a:avLst/>
+          </a:prstGeom>
+          <a:noFill/>
+        </p:spPr>
+        <p:txBody>
+          <a:bodyPr wrap="square" anchor="t" lIns="0" rIns="0" tIns="0" bIns="0">
+            <a:spAutoFit/>
+          </a:bodyPr>
+          <a:lstStyle/>
+          <a:p>
+            <a:pPr algn="l"/>
+            <a:r>
+              <a:rPr lang="en-US" sz="5400" b="1">
+                <a:solidFill>
+                  <a:srgbClr val="F7F6F2"/>
+                </a:solidFill>
+                <a:latin typeface="Arial"/>
+              </a:rPr>
+              <a:t>Digital Advertising</a:t>
+            </a:r>
+          </a:p>
+        </p:txBody>
+      </p:sp>
+      <p:sp>
+        <p:nvSpPr>
+          <p:cNvPr id="5" name="Page number"/>
+          <p:cNvSpPr txBox="1"/>
+          <p:nvPr/>
+        </p:nvSpPr>
+        <p:spPr>
+          <a:xfrm>
+            <a:off x="11094415" y="6355080"/>
+            <a:ext cx="548640" cy="274320"/>
+          </a:xfrm>
+          <a:prstGeom prst="rect">
+            <a:avLst/>
+          </a:prstGeom>
+          <a:noFill/>
+        </p:spPr>
+        <p:txBody>
+          <a:bodyPr wrap="square" anchor="t" lIns="0" rIns="0" tIns="0" bIns="0">
+            <a:spAutoFit/>
+          </a:bodyPr>
+          <a:lstStyle/>
+          <a:p>
+            <a:pPr algn="r"/>
+            <a:r>
+              <a:rPr lang="en-US" sz="1000" b="0">
+                <a:solidFill>
+                  <a:srgbClr val="9FB0C9"/>
+                </a:solidFill>
+                <a:latin typeface="Arial"/>
+              </a:rPr>
+              <a:t>4</a:t>
+            </a:r>
+          </a:p>
+        </p:txBody>
+      </p:sp>
+    </p:spTree>
+  </p:cSld>
+  <p:clrMapOvr>
+    <a:masterClrMapping/>
+  </p:clrMapOvr>
+</p:sld>
+</file>
+
 <file path=ppt/slides/slide2.xml><?xml version="1.0" encoding="utf-8"?>
 <p:sld xmlns:a="http://schemas.openxmlformats.org/drawingml/2006/main" xmlns:p="http://schemas.openxmlformats.org/presentationml/2006/main" xmlns:r="http://schemas.openxmlformats.org/officeDocument/2006/relationships">
   <p:cSld>
@@ -12428,7 +12560,7 @@
                 </a:solidFill>
                 <a:latin typeface="Arial"/>
               </a:rPr>
-              <a:t>4</a:t>
+              <a:t>5</a:t>
             </a:r>
           </a:p>
         </p:txBody>
@@ -13929,7 +14061,7 @@
                 </a:solidFill>
                 <a:latin typeface="Arial"/>
               </a:rPr>
-              <a:t>5</a:t>
+              <a:t>6</a:t>
             </a:r>
           </a:p>
         </p:txBody>
@@ -14716,7 +14848,7 @@
                 </a:solidFill>
                 <a:latin typeface="Arial"/>
               </a:rPr>
-              <a:t>6</a:t>
+              <a:t>7</a:t>
             </a:r>
           </a:p>
         </p:txBody>
@@ -16417,7 +16549,7 @@
                 </a:solidFill>
                 <a:latin typeface="Arial"/>
               </a:rPr>
-              <a:t>7</a:t>
+              <a:t>8</a:t>
             </a:r>
           </a:p>
         </p:txBody>
@@ -17593,7 +17725,7 @@
                 </a:solidFill>
                 <a:latin typeface="Arial"/>
               </a:rPr>
-              <a:t>8</a:t>
+              <a:t>9</a:t>
             </a:r>
           </a:p>
         </p:txBody>
@@ -20360,7 +20492,7 @@
                 </a:solidFill>
                 <a:latin typeface="Arial"/>
               </a:rPr>
-              <a:t>9</a:t>
+              <a:t>10</a:t>
             </a:r>
           </a:p>
         </p:txBody>
@@ -23127,7 +23259,7 @@
                 </a:solidFill>
                 <a:latin typeface="Arial"/>
               </a:rPr>
-              <a:t>10</a:t>
+              <a:t>11</a:t>
             </a:r>
           </a:p>
         </p:txBody>

</xml_diff>

<commit_message>
Add A Customer's Journey touchpoint slide
Co-Authored-By: Claude Opus 5.5 <noreply@anthropic.com>
Claude-Session: https://claude.ai/code/session_01Uh1Zy2kJM6EXCLGhh2VL1n
</commit_message>
<xml_diff>
--- a/Coastal-Air-Plus-YTD-Performance-Sep2026.pptx
+++ b/Coastal-Air-Plus-YTD-Performance-Sep2026.pptx
@@ -7,6 +7,7 @@
   <p:sldIdLst>
     <p:sldId id="256" r:id="rId7"/>
     <p:sldId id="268" r:id="rId20"/>
+    <p:sldId id="270" r:id="rId22"/>
     <p:sldId id="257" r:id="rId9"/>
     <p:sldId id="269" r:id="rId21"/>
     <p:sldId id="258" r:id="rId10"/>
@@ -4647,7 +4648,7 @@
                 </a:solidFill>
                 <a:latin typeface="Arial"/>
               </a:rPr>
-              <a:t>12</a:t>
+              <a:t>13</a:t>
             </a:r>
           </a:p>
         </p:txBody>
@@ -7414,7 +7415,7 @@
                 </a:solidFill>
                 <a:latin typeface="Arial"/>
               </a:rPr>
-              <a:t>13</a:t>
+              <a:t>14</a:t>
             </a:r>
           </a:p>
         </p:txBody>
@@ -11380,7 +11381,783 @@
                 </a:solidFill>
                 <a:latin typeface="Arial"/>
               </a:rPr>
-              <a:t>4</a:t>
+              <a:t>5</a:t>
+            </a:r>
+          </a:p>
+        </p:txBody>
+      </p:sp>
+    </p:spTree>
+  </p:cSld>
+  <p:clrMapOvr>
+    <a:masterClrMapping/>
+  </p:clrMapOvr>
+</p:sld>
+</file>
+
+<file path=ppt/slides/slide15.xml><?xml version="1.0" encoding="utf-8"?>
+<p:sld xmlns:a="http://schemas.openxmlformats.org/drawingml/2006/main" xmlns:p="http://schemas.openxmlformats.org/presentationml/2006/main" xmlns:r="http://schemas.openxmlformats.org/officeDocument/2006/relationships">
+  <p:cSld>
+    <p:bg>
+      <p:bgPr>
+        <a:solidFill>
+          <a:srgbClr val="F7F6F2"/>
+        </a:solidFill>
+        <a:effectLst/>
+      </p:bgPr>
+    </p:bg>
+    <p:spTree>
+      <p:nvGrpSpPr>
+        <p:cNvPr id="1" name=""/>
+        <p:cNvGrpSpPr/>
+        <p:nvPr/>
+      </p:nvGrpSpPr>
+      <p:grpSpPr/>
+      <p:sp>
+        <p:nvSpPr>
+          <p:cNvPr id="2" name="Title"/>
+          <p:cNvSpPr txBox="1"/>
+          <p:nvPr/>
+        </p:nvSpPr>
+        <p:spPr>
+          <a:xfrm>
+            <a:off x="548640" y="411480"/>
+            <a:ext cx="11094415" cy="822960"/>
+          </a:xfrm>
+          <a:prstGeom prst="rect">
+            <a:avLst/>
+          </a:prstGeom>
+          <a:noFill/>
+        </p:spPr>
+        <p:txBody>
+          <a:bodyPr wrap="square" anchor="t" lIns="0" rIns="0" tIns="0" bIns="0">
+            <a:spAutoFit/>
+          </a:bodyPr>
+          <a:lstStyle/>
+          <a:p>
+            <a:pPr algn="l"/>
+            <a:r>
+              <a:rPr lang="en-US" sz="2800" b="1">
+                <a:solidFill>
+                  <a:srgbClr val="14213D"/>
+                </a:solidFill>
+                <a:latin typeface="Arial"/>
+              </a:rPr>
+              <a:t>A Customer’s Journey</a:t>
+            </a:r>
+          </a:p>
+        </p:txBody>
+      </p:sp>
+      <p:cxnSp>
+        <p:nvCxnSpPr>
+          <p:cNvPr id="3" name="Connector"/>
+          <p:cNvCxnSpPr/>
+          <p:nvPr/>
+        </p:nvCxnSpPr>
+        <p:spPr>
+          <a:xfrm>
+            <a:off x="6096000" y="1931920"/>
+            <a:ext cx="0" cy="2000000"/>
+          </a:xfrm>
+          <a:prstGeom prst="line">
+            <a:avLst/>
+          </a:prstGeom>
+          <a:ln w="12700">
+            <a:solidFill>
+              <a:srgbClr val="C9CDD6"/>
+            </a:solidFill>
+            <a:prstDash val="dash"/>
+          </a:ln>
+        </p:spPr>
+      </p:cxnSp>
+      <p:cxnSp>
+        <p:nvCxnSpPr>
+          <p:cNvPr id="4" name="Connector"/>
+          <p:cNvCxnSpPr/>
+          <p:nvPr/>
+        </p:nvCxnSpPr>
+        <p:spPr>
+          <a:xfrm flipV="1">
+            <a:off x="6096000" y="2313886"/>
+            <a:ext cx="2703812" cy="1618034"/>
+          </a:xfrm>
+          <a:prstGeom prst="line">
+            <a:avLst/>
+          </a:prstGeom>
+          <a:ln w="12700">
+            <a:solidFill>
+              <a:srgbClr val="C9CDD6"/>
+            </a:solidFill>
+            <a:prstDash val="dash"/>
+          </a:ln>
+        </p:spPr>
+      </p:cxnSp>
+      <p:cxnSp>
+        <p:nvCxnSpPr>
+          <p:cNvPr id="5" name="Connector"/>
+          <p:cNvCxnSpPr/>
+          <p:nvPr/>
+        </p:nvCxnSpPr>
+        <p:spPr>
+          <a:xfrm flipV="1">
+            <a:off x="6096000" y="3313886"/>
+            <a:ext cx="4374859" cy="618034"/>
+          </a:xfrm>
+          <a:prstGeom prst="line">
+            <a:avLst/>
+          </a:prstGeom>
+          <a:ln w="12700">
+            <a:solidFill>
+              <a:srgbClr val="C9CDD6"/>
+            </a:solidFill>
+            <a:prstDash val="dash"/>
+          </a:ln>
+        </p:spPr>
+      </p:cxnSp>
+      <p:cxnSp>
+        <p:nvCxnSpPr>
+          <p:cNvPr id="6" name="Connector"/>
+          <p:cNvCxnSpPr/>
+          <p:nvPr/>
+        </p:nvCxnSpPr>
+        <p:spPr>
+          <a:xfrm>
+            <a:off x="6096000" y="3931920"/>
+            <a:ext cx="4374859" cy="618033"/>
+          </a:xfrm>
+          <a:prstGeom prst="line">
+            <a:avLst/>
+          </a:prstGeom>
+          <a:ln w="12700">
+            <a:solidFill>
+              <a:srgbClr val="C9CDD6"/>
+            </a:solidFill>
+            <a:prstDash val="dash"/>
+          </a:ln>
+        </p:spPr>
+      </p:cxnSp>
+      <p:cxnSp>
+        <p:nvCxnSpPr>
+          <p:cNvPr id="7" name="Connector"/>
+          <p:cNvCxnSpPr/>
+          <p:nvPr/>
+        </p:nvCxnSpPr>
+        <p:spPr>
+          <a:xfrm>
+            <a:off x="6096000" y="3931920"/>
+            <a:ext cx="2703812" cy="1618033"/>
+          </a:xfrm>
+          <a:prstGeom prst="line">
+            <a:avLst/>
+          </a:prstGeom>
+          <a:ln w="12700">
+            <a:solidFill>
+              <a:srgbClr val="C9CDD6"/>
+            </a:solidFill>
+            <a:prstDash val="dash"/>
+          </a:ln>
+        </p:spPr>
+      </p:cxnSp>
+      <p:cxnSp>
+        <p:nvCxnSpPr>
+          <p:cNvPr id="8" name="Connector"/>
+          <p:cNvCxnSpPr/>
+          <p:nvPr/>
+        </p:nvCxnSpPr>
+        <p:spPr>
+          <a:xfrm>
+            <a:off x="6096000" y="3931920"/>
+            <a:ext cx="0" cy="2000000"/>
+          </a:xfrm>
+          <a:prstGeom prst="line">
+            <a:avLst/>
+          </a:prstGeom>
+          <a:ln w="12700">
+            <a:solidFill>
+              <a:srgbClr val="C9CDD6"/>
+            </a:solidFill>
+            <a:prstDash val="dash"/>
+          </a:ln>
+        </p:spPr>
+      </p:cxnSp>
+      <p:cxnSp>
+        <p:nvCxnSpPr>
+          <p:cNvPr id="9" name="Connector"/>
+          <p:cNvCxnSpPr/>
+          <p:nvPr/>
+        </p:nvCxnSpPr>
+        <p:spPr>
+          <a:xfrm flipV="1">
+            <a:off x="3392187" y="3931920"/>
+            <a:ext cx="2703813" cy="1618033"/>
+          </a:xfrm>
+          <a:prstGeom prst="line">
+            <a:avLst/>
+          </a:prstGeom>
+          <a:ln w="12700">
+            <a:solidFill>
+              <a:srgbClr val="C9CDD6"/>
+            </a:solidFill>
+            <a:prstDash val="dash"/>
+          </a:ln>
+        </p:spPr>
+      </p:cxnSp>
+      <p:cxnSp>
+        <p:nvCxnSpPr>
+          <p:cNvPr id="10" name="Connector"/>
+          <p:cNvCxnSpPr/>
+          <p:nvPr/>
+        </p:nvCxnSpPr>
+        <p:spPr>
+          <a:xfrm flipV="1">
+            <a:off x="1721140" y="3931920"/>
+            <a:ext cx="4374860" cy="618033"/>
+          </a:xfrm>
+          <a:prstGeom prst="line">
+            <a:avLst/>
+          </a:prstGeom>
+          <a:ln w="12700">
+            <a:solidFill>
+              <a:srgbClr val="C9CDD6"/>
+            </a:solidFill>
+            <a:prstDash val="dash"/>
+          </a:ln>
+        </p:spPr>
+      </p:cxnSp>
+      <p:cxnSp>
+        <p:nvCxnSpPr>
+          <p:cNvPr id="11" name="Connector"/>
+          <p:cNvCxnSpPr/>
+          <p:nvPr/>
+        </p:nvCxnSpPr>
+        <p:spPr>
+          <a:xfrm>
+            <a:off x="1721140" y="3313886"/>
+            <a:ext cx="4374860" cy="618034"/>
+          </a:xfrm>
+          <a:prstGeom prst="line">
+            <a:avLst/>
+          </a:prstGeom>
+          <a:ln w="12700">
+            <a:solidFill>
+              <a:srgbClr val="C9CDD6"/>
+            </a:solidFill>
+            <a:prstDash val="dash"/>
+          </a:ln>
+        </p:spPr>
+      </p:cxnSp>
+      <p:cxnSp>
+        <p:nvCxnSpPr>
+          <p:cNvPr id="12" name="Connector"/>
+          <p:cNvCxnSpPr/>
+          <p:nvPr/>
+        </p:nvCxnSpPr>
+        <p:spPr>
+          <a:xfrm>
+            <a:off x="3392187" y="2313886"/>
+            <a:ext cx="2703813" cy="1618034"/>
+          </a:xfrm>
+          <a:prstGeom prst="line">
+            <a:avLst/>
+          </a:prstGeom>
+          <a:ln w="12700">
+            <a:solidFill>
+              <a:srgbClr val="C9CDD6"/>
+            </a:solidFill>
+            <a:prstDash val="dash"/>
+          </a:ln>
+        </p:spPr>
+      </p:cxnSp>
+      <p:sp>
+        <p:nvSpPr>
+          <p:cNvPr id="13" name="Customer"/>
+          <p:cNvSpPr/>
+          <p:nvPr/>
+        </p:nvSpPr>
+        <p:spPr>
+          <a:xfrm>
+            <a:off x="5227320" y="3063240"/>
+            <a:ext cx="1737360" cy="1737360"/>
+          </a:xfrm>
+          <a:prstGeom prst="ellipse">
+            <a:avLst/>
+          </a:prstGeom>
+          <a:solidFill>
+            <a:srgbClr val="14213D"/>
+          </a:solidFill>
+          <a:ln w="12700">
+            <a:solidFill>
+              <a:srgbClr val="14213D"/>
+            </a:solidFill>
+          </a:ln>
+        </p:spPr>
+        <p:txBody>
+          <a:bodyPr wrap="none" anchor="ctr" lIns="91440" rIns="91440" tIns="0" bIns="0"/>
+          <a:lstStyle/>
+          <a:p>
+            <a:pPr algn="ctr"/>
+            <a:r>
+              <a:rPr lang="en-US" sz="2000" b="1">
+                <a:solidFill>
+                  <a:srgbClr val="F7F6F2"/>
+                </a:solidFill>
+                <a:latin typeface="Arial"/>
+              </a:rPr>
+              <a:t>Customer</a:t>
+            </a:r>
+          </a:p>
+        </p:txBody>
+      </p:sp>
+      <p:sp>
+        <p:nvSpPr>
+          <p:cNvPr id="14" name="Touchpoint TV"/>
+          <p:cNvSpPr/>
+          <p:nvPr/>
+        </p:nvSpPr>
+        <p:spPr>
+          <a:xfrm>
+            <a:off x="5364480" y="1634740"/>
+            <a:ext cx="1463040" cy="594360"/>
+          </a:xfrm>
+          <a:prstGeom prst="roundRect">
+            <a:avLst>
+              <a:gd name="adj" fmla="val 50000"/>
+            </a:avLst>
+          </a:prstGeom>
+          <a:solidFill>
+            <a:srgbClr val="FFFFFF"/>
+          </a:solidFill>
+          <a:ln w="12700">
+            <a:solidFill>
+              <a:srgbClr val="E2E0D8"/>
+            </a:solidFill>
+          </a:ln>
+        </p:spPr>
+        <p:txBody>
+          <a:bodyPr wrap="none" anchor="ctr" lIns="91440" rIns="91440" tIns="0" bIns="0"/>
+          <a:lstStyle/>
+          <a:p>
+            <a:pPr algn="ctr"/>
+            <a:r>
+              <a:rPr lang="en-US" sz="1600" b="1">
+                <a:solidFill>
+                  <a:srgbClr val="14213D"/>
+                </a:solidFill>
+                <a:latin typeface="Arial"/>
+              </a:rPr>
+              <a:t>TV</a:t>
+            </a:r>
+          </a:p>
+        </p:txBody>
+      </p:sp>
+      <p:sp>
+        <p:nvSpPr>
+          <p:cNvPr id="15" name="Touchpoint Direct Mail"/>
+          <p:cNvSpPr/>
+          <p:nvPr/>
+        </p:nvSpPr>
+        <p:spPr>
+          <a:xfrm>
+            <a:off x="7944848" y="2016706"/>
+            <a:ext cx="1709928" cy="594360"/>
+          </a:xfrm>
+          <a:prstGeom prst="roundRect">
+            <a:avLst>
+              <a:gd name="adj" fmla="val 50000"/>
+            </a:avLst>
+          </a:prstGeom>
+          <a:solidFill>
+            <a:srgbClr val="FFFFFF"/>
+          </a:solidFill>
+          <a:ln w="12700">
+            <a:solidFill>
+              <a:srgbClr val="E2E0D8"/>
+            </a:solidFill>
+          </a:ln>
+        </p:spPr>
+        <p:txBody>
+          <a:bodyPr wrap="none" anchor="ctr" lIns="91440" rIns="91440" tIns="0" bIns="0"/>
+          <a:lstStyle/>
+          <a:p>
+            <a:pPr algn="ctr"/>
+            <a:r>
+              <a:rPr lang="en-US" sz="1600" b="1">
+                <a:solidFill>
+                  <a:srgbClr val="14213D"/>
+                </a:solidFill>
+                <a:latin typeface="Arial"/>
+              </a:rPr>
+              <a:t>Direct Mail</a:t>
+            </a:r>
+          </a:p>
+        </p:txBody>
+      </p:sp>
+      <p:sp>
+        <p:nvSpPr>
+          <p:cNvPr id="16" name="Touchpoint GBP"/>
+          <p:cNvSpPr/>
+          <p:nvPr/>
+        </p:nvSpPr>
+        <p:spPr>
+          <a:xfrm>
+            <a:off x="9739339" y="3016706"/>
+            <a:ext cx="1463040" cy="594360"/>
+          </a:xfrm>
+          <a:prstGeom prst="roundRect">
+            <a:avLst>
+              <a:gd name="adj" fmla="val 50000"/>
+            </a:avLst>
+          </a:prstGeom>
+          <a:solidFill>
+            <a:srgbClr val="FFFFFF"/>
+          </a:solidFill>
+          <a:ln w="12700">
+            <a:solidFill>
+              <a:srgbClr val="E2E0D8"/>
+            </a:solidFill>
+          </a:ln>
+        </p:spPr>
+        <p:txBody>
+          <a:bodyPr wrap="none" anchor="ctr" lIns="91440" rIns="91440" tIns="0" bIns="0"/>
+          <a:lstStyle/>
+          <a:p>
+            <a:pPr algn="ctr"/>
+            <a:r>
+              <a:rPr lang="en-US" sz="1600" b="1">
+                <a:solidFill>
+                  <a:srgbClr val="14213D"/>
+                </a:solidFill>
+                <a:latin typeface="Arial"/>
+              </a:rPr>
+              <a:t>GBP</a:t>
+            </a:r>
+          </a:p>
+        </p:txBody>
+      </p:sp>
+      <p:sp>
+        <p:nvSpPr>
+          <p:cNvPr id="17" name="Touchpoint Website"/>
+          <p:cNvSpPr/>
+          <p:nvPr/>
+        </p:nvSpPr>
+        <p:spPr>
+          <a:xfrm>
+            <a:off x="9739339" y="4252773"/>
+            <a:ext cx="1463040" cy="594360"/>
+          </a:xfrm>
+          <a:prstGeom prst="roundRect">
+            <a:avLst>
+              <a:gd name="adj" fmla="val 50000"/>
+            </a:avLst>
+          </a:prstGeom>
+          <a:solidFill>
+            <a:srgbClr val="FFFFFF"/>
+          </a:solidFill>
+          <a:ln w="12700">
+            <a:solidFill>
+              <a:srgbClr val="E2E0D8"/>
+            </a:solidFill>
+          </a:ln>
+        </p:spPr>
+        <p:txBody>
+          <a:bodyPr wrap="none" anchor="ctr" lIns="91440" rIns="91440" tIns="0" bIns="0"/>
+          <a:lstStyle/>
+          <a:p>
+            <a:pPr algn="ctr"/>
+            <a:r>
+              <a:rPr lang="en-US" sz="1600" b="1">
+                <a:solidFill>
+                  <a:srgbClr val="14213D"/>
+                </a:solidFill>
+                <a:latin typeface="Arial"/>
+              </a:rPr>
+              <a:t>Website</a:t>
+            </a:r>
+          </a:p>
+        </p:txBody>
+      </p:sp>
+      <p:sp>
+        <p:nvSpPr>
+          <p:cNvPr id="18" name="Touchpoint Promos"/>
+          <p:cNvSpPr/>
+          <p:nvPr/>
+        </p:nvSpPr>
+        <p:spPr>
+          <a:xfrm>
+            <a:off x="8068292" y="5252773"/>
+            <a:ext cx="1463040" cy="594360"/>
+          </a:xfrm>
+          <a:prstGeom prst="roundRect">
+            <a:avLst>
+              <a:gd name="adj" fmla="val 50000"/>
+            </a:avLst>
+          </a:prstGeom>
+          <a:solidFill>
+            <a:srgbClr val="FFFFFF"/>
+          </a:solidFill>
+          <a:ln w="12700">
+            <a:solidFill>
+              <a:srgbClr val="E2E0D8"/>
+            </a:solidFill>
+          </a:ln>
+        </p:spPr>
+        <p:txBody>
+          <a:bodyPr wrap="none" anchor="ctr" lIns="91440" rIns="91440" tIns="0" bIns="0"/>
+          <a:lstStyle/>
+          <a:p>
+            <a:pPr algn="ctr"/>
+            <a:r>
+              <a:rPr lang="en-US" sz="1600" b="1">
+                <a:solidFill>
+                  <a:srgbClr val="14213D"/>
+                </a:solidFill>
+                <a:latin typeface="Arial"/>
+              </a:rPr>
+              <a:t>Promos</a:t>
+            </a:r>
+          </a:p>
+        </p:txBody>
+      </p:sp>
+      <p:sp>
+        <p:nvSpPr>
+          <p:cNvPr id="19" name="Touchpoint Outbound Text Campaigns"/>
+          <p:cNvSpPr/>
+          <p:nvPr/>
+        </p:nvSpPr>
+        <p:spPr>
+          <a:xfrm>
+            <a:off x="4582669" y="5634740"/>
+            <a:ext cx="3026663" cy="594360"/>
+          </a:xfrm>
+          <a:prstGeom prst="roundRect">
+            <a:avLst>
+              <a:gd name="adj" fmla="val 50000"/>
+            </a:avLst>
+          </a:prstGeom>
+          <a:solidFill>
+            <a:srgbClr val="FFFFFF"/>
+          </a:solidFill>
+          <a:ln w="12700">
+            <a:solidFill>
+              <a:srgbClr val="E2E0D8"/>
+            </a:solidFill>
+          </a:ln>
+        </p:spPr>
+        <p:txBody>
+          <a:bodyPr wrap="none" anchor="ctr" lIns="91440" rIns="91440" tIns="0" bIns="0"/>
+          <a:lstStyle/>
+          <a:p>
+            <a:pPr algn="ctr"/>
+            <a:r>
+              <a:rPr lang="en-US" sz="1600" b="1">
+                <a:solidFill>
+                  <a:srgbClr val="14213D"/>
+                </a:solidFill>
+                <a:latin typeface="Arial"/>
+              </a:rPr>
+              <a:t>Outbound Text Campaigns</a:t>
+            </a:r>
+          </a:p>
+        </p:txBody>
+      </p:sp>
+      <p:sp>
+        <p:nvSpPr>
+          <p:cNvPr id="20" name="Touchpoint Inbound"/>
+          <p:cNvSpPr/>
+          <p:nvPr/>
+        </p:nvSpPr>
+        <p:spPr>
+          <a:xfrm>
+            <a:off x="2660667" y="5252773"/>
+            <a:ext cx="1463040" cy="594360"/>
+          </a:xfrm>
+          <a:prstGeom prst="roundRect">
+            <a:avLst>
+              <a:gd name="adj" fmla="val 50000"/>
+            </a:avLst>
+          </a:prstGeom>
+          <a:solidFill>
+            <a:srgbClr val="FFFFFF"/>
+          </a:solidFill>
+          <a:ln w="12700">
+            <a:solidFill>
+              <a:srgbClr val="E2E0D8"/>
+            </a:solidFill>
+          </a:ln>
+        </p:spPr>
+        <p:txBody>
+          <a:bodyPr wrap="none" anchor="ctr" lIns="91440" rIns="91440" tIns="0" bIns="0"/>
+          <a:lstStyle/>
+          <a:p>
+            <a:pPr algn="ctr"/>
+            <a:r>
+              <a:rPr lang="en-US" sz="1600" b="1">
+                <a:solidFill>
+                  <a:srgbClr val="14213D"/>
+                </a:solidFill>
+                <a:latin typeface="Arial"/>
+              </a:rPr>
+              <a:t>Inbound</a:t>
+            </a:r>
+          </a:p>
+        </p:txBody>
+      </p:sp>
+      <p:sp>
+        <p:nvSpPr>
+          <p:cNvPr id="21" name="Touchpoint Facebook"/>
+          <p:cNvSpPr/>
+          <p:nvPr/>
+        </p:nvSpPr>
+        <p:spPr>
+          <a:xfrm>
+            <a:off x="989620" y="4252773"/>
+            <a:ext cx="1463040" cy="594360"/>
+          </a:xfrm>
+          <a:prstGeom prst="roundRect">
+            <a:avLst>
+              <a:gd name="adj" fmla="val 50000"/>
+            </a:avLst>
+          </a:prstGeom>
+          <a:solidFill>
+            <a:srgbClr val="FFFFFF"/>
+          </a:solidFill>
+          <a:ln w="12700">
+            <a:solidFill>
+              <a:srgbClr val="E2E0D8"/>
+            </a:solidFill>
+          </a:ln>
+        </p:spPr>
+        <p:txBody>
+          <a:bodyPr wrap="none" anchor="ctr" lIns="91440" rIns="91440" tIns="0" bIns="0"/>
+          <a:lstStyle/>
+          <a:p>
+            <a:pPr algn="ctr"/>
+            <a:r>
+              <a:rPr lang="en-US" sz="1600" b="1">
+                <a:solidFill>
+                  <a:srgbClr val="14213D"/>
+                </a:solidFill>
+                <a:latin typeface="Arial"/>
+              </a:rPr>
+              <a:t>Facebook</a:t>
+            </a:r>
+          </a:p>
+        </p:txBody>
+      </p:sp>
+      <p:sp>
+        <p:nvSpPr>
+          <p:cNvPr id="22" name="Touchpoint Google Ads"/>
+          <p:cNvSpPr/>
+          <p:nvPr/>
+        </p:nvSpPr>
+        <p:spPr>
+          <a:xfrm>
+            <a:off x="921040" y="3016706"/>
+            <a:ext cx="1600200" cy="594360"/>
+          </a:xfrm>
+          <a:prstGeom prst="roundRect">
+            <a:avLst>
+              <a:gd name="adj" fmla="val 50000"/>
+            </a:avLst>
+          </a:prstGeom>
+          <a:solidFill>
+            <a:srgbClr val="FFFFFF"/>
+          </a:solidFill>
+          <a:ln w="12700">
+            <a:solidFill>
+              <a:srgbClr val="E2E0D8"/>
+            </a:solidFill>
+          </a:ln>
+        </p:spPr>
+        <p:txBody>
+          <a:bodyPr wrap="none" anchor="ctr" lIns="91440" rIns="91440" tIns="0" bIns="0"/>
+          <a:lstStyle/>
+          <a:p>
+            <a:pPr algn="ctr"/>
+            <a:r>
+              <a:rPr lang="en-US" sz="1600" b="1">
+                <a:solidFill>
+                  <a:srgbClr val="14213D"/>
+                </a:solidFill>
+                <a:latin typeface="Arial"/>
+              </a:rPr>
+              <a:t>Google Ads</a:t>
+            </a:r>
+          </a:p>
+        </p:txBody>
+      </p:sp>
+      <p:sp>
+        <p:nvSpPr>
+          <p:cNvPr id="23" name="Touchpoint Fleetworx"/>
+          <p:cNvSpPr/>
+          <p:nvPr/>
+        </p:nvSpPr>
+        <p:spPr>
+          <a:xfrm>
+            <a:off x="2646951" y="2016706"/>
+            <a:ext cx="1490472" cy="594360"/>
+          </a:xfrm>
+          <a:prstGeom prst="roundRect">
+            <a:avLst>
+              <a:gd name="adj" fmla="val 50000"/>
+            </a:avLst>
+          </a:prstGeom>
+          <a:solidFill>
+            <a:srgbClr val="FFFFFF"/>
+          </a:solidFill>
+          <a:ln w="12700">
+            <a:solidFill>
+              <a:srgbClr val="E2E0D8"/>
+            </a:solidFill>
+          </a:ln>
+        </p:spPr>
+        <p:txBody>
+          <a:bodyPr wrap="none" anchor="ctr" lIns="91440" rIns="91440" tIns="0" bIns="0"/>
+          <a:lstStyle/>
+          <a:p>
+            <a:pPr algn="ctr"/>
+            <a:r>
+              <a:rPr lang="en-US" sz="1600" b="1">
+                <a:solidFill>
+                  <a:srgbClr val="14213D"/>
+                </a:solidFill>
+                <a:latin typeface="Arial"/>
+              </a:rPr>
+              <a:t>Fleetworx</a:t>
+            </a:r>
+          </a:p>
+        </p:txBody>
+      </p:sp>
+      <p:sp>
+        <p:nvSpPr>
+          <p:cNvPr id="24" name="Page number"/>
+          <p:cNvSpPr txBox="1"/>
+          <p:nvPr/>
+        </p:nvSpPr>
+        <p:spPr>
+          <a:xfrm>
+            <a:off x="11094415" y="6355080"/>
+            <a:ext cx="548640" cy="274320"/>
+          </a:xfrm>
+          <a:prstGeom prst="rect">
+            <a:avLst/>
+          </a:prstGeom>
+          <a:noFill/>
+        </p:spPr>
+        <p:txBody>
+          <a:bodyPr wrap="square" anchor="t" lIns="0" rIns="0" tIns="0" bIns="0">
+            <a:spAutoFit/>
+          </a:bodyPr>
+          <a:lstStyle/>
+          <a:p>
+            <a:pPr algn="r"/>
+            <a:r>
+              <a:rPr lang="en-US" sz="1000" b="0">
+                <a:solidFill>
+                  <a:srgbClr val="5A6478"/>
+                </a:solidFill>
+                <a:latin typeface="Arial"/>
+              </a:rPr>
+              <a:t>3</a:t>
             </a:r>
           </a:p>
         </p:txBody>
@@ -11511,7 +12288,7 @@
                 </a:solidFill>
                 <a:latin typeface="Arial"/>
               </a:rPr>
-              <a:t>3</a:t>
+              <a:t>4</a:t>
             </a:r>
           </a:p>
         </p:txBody>
@@ -12560,7 +13337,7 @@
                 </a:solidFill>
                 <a:latin typeface="Arial"/>
               </a:rPr>
-              <a:t>5</a:t>
+              <a:t>6</a:t>
             </a:r>
           </a:p>
         </p:txBody>
@@ -14061,7 +14838,7 @@
                 </a:solidFill>
                 <a:latin typeface="Arial"/>
               </a:rPr>
-              <a:t>6</a:t>
+              <a:t>7</a:t>
             </a:r>
           </a:p>
         </p:txBody>
@@ -14848,7 +15625,7 @@
                 </a:solidFill>
                 <a:latin typeface="Arial"/>
               </a:rPr>
-              <a:t>7</a:t>
+              <a:t>8</a:t>
             </a:r>
           </a:p>
         </p:txBody>
@@ -16549,7 +17326,7 @@
                 </a:solidFill>
                 <a:latin typeface="Arial"/>
               </a:rPr>
-              <a:t>8</a:t>
+              <a:t>9</a:t>
             </a:r>
           </a:p>
         </p:txBody>
@@ -17725,7 +18502,7 @@
                 </a:solidFill>
                 <a:latin typeface="Arial"/>
               </a:rPr>
-              <a:t>9</a:t>
+              <a:t>10</a:t>
             </a:r>
           </a:p>
         </p:txBody>
@@ -20492,7 +21269,7 @@
                 </a:solidFill>
                 <a:latin typeface="Arial"/>
               </a:rPr>
-              <a:t>10</a:t>
+              <a:t>11</a:t>
             </a:r>
           </a:p>
         </p:txBody>
@@ -23259,7 +24036,7 @@
                 </a:solidFill>
                 <a:latin typeface="Arial"/>
               </a:rPr>
-              <a:t>11</a:t>
+              <a:t>12</a:t>
             </a:r>
           </a:p>
         </p:txBody>

</xml_diff>

<commit_message>
Move Customer's Journey slide to position 2
Co-Authored-By: Claude Opus 5.5 <noreply@anthropic.com>
Claude-Session: https://claude.ai/code/session_01Uh1Zy2kJM6EXCLGhh2VL1n
</commit_message>
<xml_diff>
--- a/Coastal-Air-Plus-YTD-Performance-Sep2026.pptx
+++ b/Coastal-Air-Plus-YTD-Performance-Sep2026.pptx
@@ -6,8 +6,8 @@
   </p:sldMasterIdLst>
   <p:sldIdLst>
     <p:sldId id="256" r:id="rId7"/>
+    <p:sldId id="270" r:id="rId22"/>
     <p:sldId id="268" r:id="rId20"/>
-    <p:sldId id="270" r:id="rId22"/>
     <p:sldId id="257" r:id="rId9"/>
     <p:sldId id="269" r:id="rId21"/>
     <p:sldId id="258" r:id="rId10"/>
@@ -10337,7 +10337,7 @@
                 </a:solidFill>
                 <a:latin typeface="Arial"/>
               </a:rPr>
-              <a:t>2</a:t>
+              <a:t>3</a:t>
             </a:r>
           </a:p>
         </p:txBody>
@@ -12157,7 +12157,7 @@
                 </a:solidFill>
                 <a:latin typeface="Arial"/>
               </a:rPr>
-              <a:t>3</a:t>
+              <a:t>2</a:t>
             </a:r>
           </a:p>
         </p:txBody>

</xml_diff>

<commit_message>
Update ad spend to $173,871 and recompute derived metrics in deck
Co-Authored-By: Claude Opus 5.5 <noreply@anthropic.com>
Claude-Session: https://claude.ai/code/session_01Uh1Zy2kJM6EXCLGhh2VL1n
</commit_message>
<xml_diff>
--- a/Coastal-Air-Plus-YTD-Performance-Sep2026.pptx
+++ b/Coastal-Air-Plus-YTD-Performance-Sep2026.pptx
@@ -726,7 +726,7 @@
           <a:lstStyle/>
           <a:p>
             <a:r>
-              <a:t>Two caveats matter when comparing to the live report: unique leads are summed by month so may be slightly higher, and about 9 thousand of ad spend is not tied to a named campaign.</a:t>
+              <a:t>Two caveats matter when comparing to the live report: unique leads are summed by month so may be slightly higher, and about 24 thousand of ad spend is not tied to a named campaign.</a:t>
             </a:r>
           </a:p>
         </p:txBody>
@@ -866,7 +866,7 @@
           <a:lstStyle/>
           <a:p>
             <a:r>
-              <a:t>Just over a million dollars closed year to date on about 159 thousand in ad spend. The 6.7x return counts revenue from all channels, including organic and direct, against ad spend. Paid advertising on its own returned 2.7x.</a:t>
+              <a:t>Just over a million dollars closed year to date on about 174 thousand in ad spend. The 6.1x return counts revenue from all channels, including organic and direct, against ad spend. Paid advertising on its own returned 2.5x.</a:t>
             </a:r>
           </a:p>
         </p:txBody>
@@ -936,7 +936,7 @@
           <a:lstStyle/>
           <a:p>
             <a:r>
-              <a:t>Advertising is the biggest channel at 1,898 leads and 436 thousand closed, a 2.7x return. Organic, mainly the two Google Business Profile listings and Google organic search, brings 1,288 leads and 368 thousand without media spend.</a:t>
+              <a:t>Advertising is the biggest channel at 1,898 leads and 436 thousand closed, a 2.5x return. Organic, mainly the two Google Business Profile listings and Google organic search, brings 1,288 leads and 368 thousand without media spend.</a:t>
             </a:r>
           </a:p>
         </p:txBody>
@@ -9763,7 +9763,7 @@
                           </a:solidFill>
                           <a:latin typeface="Arial"/>
                         </a:rPr>
-                        <a:t>$9,316</a:t>
+                        <a:t>$23,991</a:t>
                       </a:r>
                     </a:p>
                   </a:txBody>
@@ -10206,7 +10206,7 @@
                 </a:solidFill>
                 <a:latin typeface="Arial"/>
               </a:rPr>
-              <a:t>$9,316 of Advertising spend has no campaign name. It is in every total but not in any campaign row.</a:t>
+              <a:t>$23,991 of Advertising spend has no campaign name. It is in every total but not in any campaign row.</a:t>
             </a:r>
           </a:p>
         </p:txBody>
@@ -12218,7 +12218,7 @@
                 </a:solidFill>
                 <a:latin typeface="Arial"/>
               </a:rPr>
-              <a:t>Year to date: $1.06M closed on $159K of ad spend</a:t>
+              <a:t>Year to date: $1.06M closed on $174K of ad spend</a:t>
             </a:r>
           </a:p>
         </p:txBody>
@@ -12865,7 +12865,7 @@
                 </a:solidFill>
                 <a:latin typeface="Arial"/>
               </a:rPr>
-              <a:t>$159K</a:t>
+              <a:t>$174K</a:t>
             </a:r>
           </a:p>
         </p:txBody>
@@ -12900,7 +12900,7 @@
                 </a:solidFill>
                 <a:latin typeface="Arial"/>
               </a:rPr>
-              <a:t>$159,196, all in Advertising</a:t>
+              <a:t>$173,871, all in Advertising</a:t>
             </a:r>
           </a:p>
         </p:txBody>
@@ -13018,7 +13018,7 @@
                 </a:solidFill>
                 <a:latin typeface="Arial"/>
               </a:rPr>
-              <a:t>$171</a:t>
+              <a:t>$186</a:t>
             </a:r>
           </a:p>
         </p:txBody>
@@ -13053,7 +13053,7 @@
                 </a:solidFill>
                 <a:latin typeface="Arial"/>
               </a:rPr>
-              <a:t>$41 per unique lead</a:t>
+              <a:t>$45 per unique lead</a:t>
             </a:r>
           </a:p>
         </p:txBody>
@@ -13171,7 +13171,7 @@
                 </a:solidFill>
                 <a:latin typeface="Arial"/>
               </a:rPr>
-              <a:t>6.7x</a:t>
+              <a:t>6.1x</a:t>
             </a:r>
           </a:p>
         </p:txBody>
@@ -13569,7 +13569,7 @@
                           </a:solidFill>
                           <a:latin typeface="Arial"/>
                         </a:rPr>
-                        <a:t>$159,196</a:t>
+                        <a:t>$173,871</a:t>
                       </a:r>
                     </a:p>
                   </a:txBody>
@@ -13684,7 +13684,7 @@
                           </a:solidFill>
                           <a:latin typeface="Arial"/>
                         </a:rPr>
-                        <a:t>2.74x</a:t>
+                        <a:t>2.51x</a:t>
                       </a:r>
                     </a:p>
                   </a:txBody>
@@ -14547,7 +14547,7 @@
                           </a:solidFill>
                           <a:latin typeface="Arial"/>
                         </a:rPr>
-                        <a:t>$159,196</a:t>
+                        <a:t>$173,871</a:t>
                       </a:r>
                     </a:p>
                   </a:txBody>
@@ -14662,7 +14662,7 @@
                           </a:solidFill>
                           <a:latin typeface="Arial"/>
                         </a:rPr>
-                        <a:t>6.67x</a:t>
+                        <a:t>6.10x</a:t>
                       </a:r>
                     </a:p>
                   </a:txBody>

</xml_diff>